<commit_message>
fix(annotate): 판독 디자인 v2 (Node 패리티) + 쇼케이스 PPTX 갱신
Co-Authored-By: Claude Fable 5 <noreply@anthropic.com>
</commit_message>
<xml_diff>
--- a/docs/pptx/chosin_annotate_1950.pptx
+++ b/docs/pptx/chosin_annotate_1950.pptx
@@ -577,7 +577,7 @@
           <a:lstStyle/>
           <a:p>
             <a:r>
-              <a:t>레퍼런스(서울기록원류 해설 지면)의 메타데이터 표 형식. 제목·식별번호·제작·소재·시기·권리 여섯 항목.</a:t>
+              <a:t>메타데이터 표: 제목·식별번호·제작·소재·시기·권리 여섯 항목. 브랜드 팔레트(먹색·진홍·모래)로 정리.</a:t>
             </a:r>
           </a:p>
         </p:txBody>
@@ -647,7 +647,7 @@
           <a:lstStyle/>
           <a:p>
             <a:r>
-              <a:t>마커를 순서대로 짚습니다: 인장(제작 주체) → 타이틀(공식 제작물) → PF# 타임코드(인용 좌표) → 워터마크(판본 구분). 판독은 화면에서 읽히는 것만.</a:t>
+              <a:t>점선 영역을 순서대로 짚습니다: 인장(제작 주체) → 타이틀(공식 제작물) → PF# 타임코드(인용 좌표) → 워터마크(판본 구분). 판독은 화면에서 읽히는 것만.</a:t>
             </a:r>
           </a:p>
         </p:txBody>
@@ -3873,7 +3873,7 @@
       <p:grpSpPr/>
       <p:pic>
         <p:nvPicPr>
-          <p:cNvPr id="2" name="Picture 1" descr="doc_01.jpg"/>
+          <p:cNvPr id="2" name="Picture 1" descr="doc_01_c.jpg"/>
           <p:cNvPicPr>
             <a:picLocks noChangeAspect="1"/>
           </p:cNvPicPr>
@@ -3887,8 +3887,8 @@
         </p:blipFill>
         <p:spPr>
           <a:xfrm>
-            <a:off x="2834640" y="640080"/>
-            <a:ext cx="6492240" cy="3408426"/>
+            <a:off x="2712567" y="548640"/>
+            <a:ext cx="6766560" cy="5087450"/>
           </a:xfrm>
           <a:prstGeom prst="rect">
             <a:avLst/>
@@ -3897,24 +3897,742 @@
       </p:pic>
       <p:sp>
         <p:nvSpPr>
-          <p:cNvPr id="3" name="Rectangle 2"/>
-          <p:cNvSpPr/>
+          <p:cNvPr id="3" name="TextBox 2"/>
+          <p:cNvSpPr txBox="1"/>
           <p:nvPr/>
         </p:nvSpPr>
         <p:spPr>
           <a:xfrm>
-            <a:off x="0" y="4297680"/>
-            <a:ext cx="12191695" cy="2560320"/>
+            <a:off x="548640" y="4572000"/>
+            <a:ext cx="10972800" cy="365760"/>
           </a:xfrm>
           <a:prstGeom prst="rect">
             <a:avLst/>
           </a:prstGeom>
-          <a:solidFill>
-            <a:srgbClr val="171412"/>
-          </a:solidFill>
-          <a:ln>
-            <a:noFill/>
+          <a:noFill/>
+        </p:spPr>
+        <p:txBody>
+          <a:bodyPr wrap="square">
+            <a:spAutoFit/>
+          </a:bodyPr>
+          <a:lstStyle/>
+          <a:p>
+            <a:pPr algn="l">
+              <a:lnSpc>
+                <a:spcPct val="125000"/>
+              </a:lnSpc>
+            </a:pPr>
+            <a:r>
+              <a:rPr sz="1400" b="1">
+                <a:solidFill>
+                  <a:srgbClr val="C8A24A"/>
+                </a:solidFill>
+                <a:latin typeface="맑은 고딕"/>
+              </a:rPr>
+              <a:t>프레임 판독 — 기록 해설</a:t>
+            </a:r>
+          </a:p>
+        </p:txBody>
+      </p:sp>
+      <p:sp>
+        <p:nvSpPr>
+          <p:cNvPr id="4" name="TextBox 3"/>
+          <p:cNvSpPr txBox="1"/>
+          <p:nvPr/>
+        </p:nvSpPr>
+        <p:spPr>
+          <a:xfrm>
+            <a:off x="548640" y="4983480"/>
+            <a:ext cx="11155680" cy="1097280"/>
+          </a:xfrm>
+          <a:prstGeom prst="rect">
+            <a:avLst/>
+          </a:prstGeom>
+          <a:noFill/>
+        </p:spPr>
+        <p:txBody>
+          <a:bodyPr wrap="square">
+            <a:spAutoFit/>
+          </a:bodyPr>
+          <a:lstStyle/>
+          <a:p>
+            <a:pPr algn="l">
+              <a:lnSpc>
+                <a:spcPct val="125000"/>
+              </a:lnSpc>
+            </a:pPr>
+            <a:r>
+              <a:rPr sz="4000" b="1">
+                <a:solidFill>
+                  <a:srgbClr val="E9E2D6"/>
+                </a:solidFill>
+                <a:latin typeface="맑은 고딕"/>
+              </a:rPr>
+              <a:t>기록을 해설해 드립니다</a:t>
+            </a:r>
+          </a:p>
+        </p:txBody>
+      </p:sp>
+      <p:sp>
+        <p:nvSpPr>
+          <p:cNvPr id="5" name="TextBox 4"/>
+          <p:cNvSpPr txBox="1"/>
+          <p:nvPr/>
+        </p:nvSpPr>
+        <p:spPr>
+          <a:xfrm>
+            <a:off x="548640" y="5943600"/>
+            <a:ext cx="11155680" cy="457200"/>
+          </a:xfrm>
+          <a:prstGeom prst="rect">
+            <a:avLst/>
+          </a:prstGeom>
+          <a:noFill/>
+        </p:spPr>
+        <p:txBody>
+          <a:bodyPr wrap="square">
+            <a:spAutoFit/>
+          </a:bodyPr>
+          <a:lstStyle/>
+          <a:p>
+            <a:pPr algn="l">
+              <a:lnSpc>
+                <a:spcPct val="125000"/>
+              </a:lnSpc>
+            </a:pPr>
+            <a:r>
+              <a:rPr sz="1600" b="0">
+                <a:solidFill>
+                  <a:srgbClr val="9D9384"/>
+                </a:solidFill>
+                <a:latin typeface="맑은 고딕"/>
+              </a:rPr>
+              <a:t>한 프레임에서 제작 주체·판본·권리·좌표를 읽는 법</a:t>
+            </a:r>
+          </a:p>
+        </p:txBody>
+      </p:sp>
+    </p:spTree>
+  </p:cSld>
+  <p:clrMapOvr>
+    <a:masterClrMapping/>
+  </p:clrMapOvr>
+</p:sld>
+</file>
+
+<file path=ppt/slides/slide2.xml><?xml version="1.0" encoding="utf-8"?>
+<p:sld xmlns:a="http://schemas.openxmlformats.org/drawingml/2006/main" xmlns:p="http://schemas.openxmlformats.org/presentationml/2006/main" xmlns:r="http://schemas.openxmlformats.org/officeDocument/2006/relationships">
+  <p:cSld>
+    <p:bg>
+      <p:bgPr>
+        <a:solidFill>
+          <a:srgbClr val="F5F1E8"/>
+        </a:solidFill>
+        <a:effectLst/>
+      </p:bgPr>
+    </p:bg>
+    <p:spTree>
+      <p:nvGrpSpPr>
+        <p:cNvPr id="1" name=""/>
+        <p:cNvGrpSpPr/>
+        <p:nvPr/>
+      </p:nvGrpSpPr>
+      <p:grpSpPr/>
+      <p:sp>
+        <p:nvSpPr>
+          <p:cNvPr id="2" name="TextBox 1"/>
+          <p:cNvSpPr txBox="1"/>
+          <p:nvPr/>
+        </p:nvSpPr>
+        <p:spPr>
+          <a:xfrm>
+            <a:off x="502920" y="365760"/>
+            <a:ext cx="10972800" cy="365760"/>
+          </a:xfrm>
+          <a:prstGeom prst="rect">
+            <a:avLst/>
+          </a:prstGeom>
+          <a:noFill/>
+        </p:spPr>
+        <p:txBody>
+          <a:bodyPr wrap="square">
+            <a:spAutoFit/>
+          </a:bodyPr>
+          <a:lstStyle/>
+          <a:p>
+            <a:pPr algn="l">
+              <a:lnSpc>
+                <a:spcPct val="125000"/>
+              </a:lnSpc>
+            </a:pPr>
+            <a:r>
+              <a:rPr sz="1300" b="1">
+                <a:solidFill>
+                  <a:srgbClr val="8A3033"/>
+                </a:solidFill>
+                <a:latin typeface="맑은 고딕"/>
+              </a:rPr>
+              <a:t>기록물 #1 — 기본 정보</a:t>
+            </a:r>
+          </a:p>
+        </p:txBody>
+      </p:sp>
+      <p:sp>
+        <p:nvSpPr>
+          <p:cNvPr id="3" name="TextBox 2"/>
+          <p:cNvSpPr txBox="1"/>
+          <p:nvPr/>
+        </p:nvSpPr>
+        <p:spPr>
+          <a:xfrm>
+            <a:off x="502920" y="777240"/>
+            <a:ext cx="11155680" cy="640080"/>
+          </a:xfrm>
+          <a:prstGeom prst="rect">
+            <a:avLst/>
+          </a:prstGeom>
+          <a:noFill/>
+        </p:spPr>
+        <p:txBody>
+          <a:bodyPr wrap="square">
+            <a:spAutoFit/>
+          </a:bodyPr>
+          <a:lstStyle/>
+          <a:p>
+            <a:pPr algn="l">
+              <a:lnSpc>
+                <a:spcPct val="125000"/>
+              </a:lnSpc>
+            </a:pPr>
+            <a:r>
+              <a:rPr sz="2800" b="1">
+                <a:solidFill>
+                  <a:srgbClr val="211D18"/>
+                </a:solidFill>
+                <a:latin typeface="맑은 고딕"/>
+              </a:rPr>
+              <a:t>이 필름의 신원</a:t>
+            </a:r>
+          </a:p>
+        </p:txBody>
+      </p:sp>
+      <p:graphicFrame>
+        <p:nvGraphicFramePr>
+          <p:cNvPr id="4" name="Table 3"/>
+          <p:cNvGraphicFramePr>
+            <a:graphicFrameLocks noGrp="1"/>
+          </p:cNvGraphicFramePr>
+          <p:nvPr/>
+        </p:nvGraphicFramePr>
+        <p:xfrm>
+          <a:off x="502920" y="1691640"/>
+          <a:ext cx="7863840" cy="2852928"/>
+        </p:xfrm>
+        <a:graphic>
+          <a:graphicData uri="http://schemas.openxmlformats.org/drawingml/2006/table">
+            <a:tbl>
+              <a:tblPr>
+                <a:tableStyleId>{5C22544A-7EE6-4342-B048-85BDC9FD1C3A}</a:tableStyleId>
+              </a:tblPr>
+              <a:tblGrid>
+                <a:gridCol w="1645920"/>
+                <a:gridCol w="6217920"/>
+              </a:tblGrid>
+              <a:tr h="475488">
+                <a:tc>
+                  <a:txBody>
+                    <a:bodyPr/>
+                    <a:lstStyle/>
+                    <a:p>
+                      <a:r>
+                        <a:rPr sz="1300" b="1">
+                          <a:solidFill>
+                            <a:srgbClr val="8A3033"/>
+                          </a:solidFill>
+                          <a:latin typeface="맑은 고딕"/>
+                        </a:rPr>
+                        <a:t>제목</a:t>
+                      </a:r>
+                    </a:p>
+                  </a:txBody>
+                  <a:tcPr>
+                    <a:solidFill>
+                      <a:srgbClr val="F2ECDD"/>
+                    </a:solidFill>
+                  </a:tcPr>
+                </a:tc>
+                <a:tc>
+                  <a:txBody>
+                    <a:bodyPr/>
+                    <a:lstStyle/>
+                    <a:p>
+                      <a:r>
+                        <a:rPr sz="1300" b="0">
+                          <a:solidFill>
+                            <a:srgbClr val="211D18"/>
+                          </a:solidFill>
+                          <a:latin typeface="맑은 고딕"/>
+                        </a:rPr>
+                        <a:t>Chosin to Hungnam (장진호에서 흥남으로)</a:t>
+                      </a:r>
+                    </a:p>
+                  </a:txBody>
+                  <a:tcPr>
+                    <a:solidFill>
+                      <a:srgbClr val="FFFDF7"/>
+                    </a:solidFill>
+                  </a:tcPr>
+                </a:tc>
+              </a:tr>
+              <a:tr h="475488">
+                <a:tc>
+                  <a:txBody>
+                    <a:bodyPr/>
+                    <a:lstStyle/>
+                    <a:p>
+                      <a:r>
+                        <a:rPr sz="1300" b="1">
+                          <a:solidFill>
+                            <a:srgbClr val="8A3033"/>
+                          </a:solidFill>
+                          <a:latin typeface="맑은 고딕"/>
+                        </a:rPr>
+                        <a:t>식별번호</a:t>
+                      </a:r>
+                    </a:p>
+                  </a:txBody>
+                  <a:tcPr>
+                    <a:solidFill>
+                      <a:srgbClr val="F2ECDD"/>
+                    </a:solidFill>
+                  </a:tcPr>
+                </a:tc>
+                <a:tc>
+                  <a:txBody>
+                    <a:bodyPr/>
+                    <a:lstStyle/>
+                    <a:p>
+                      <a:r>
+                        <a:rPr sz="1300" b="0">
+                          <a:solidFill>
+                            <a:srgbClr val="211D18"/>
+                          </a:solidFill>
+                          <a:latin typeface="맑은 고딕"/>
+                        </a:rPr>
+                        <a:t>archive.org 81594 · PF# 81594</a:t>
+                      </a:r>
+                    </a:p>
+                  </a:txBody>
+                  <a:tcPr>
+                    <a:solidFill>
+                      <a:srgbClr val="FFFDF7"/>
+                    </a:solidFill>
+                  </a:tcPr>
+                </a:tc>
+              </a:tr>
+              <a:tr h="475488">
+                <a:tc>
+                  <a:txBody>
+                    <a:bodyPr/>
+                    <a:lstStyle/>
+                    <a:p>
+                      <a:r>
+                        <a:rPr sz="1300" b="1">
+                          <a:solidFill>
+                            <a:srgbClr val="8A3033"/>
+                          </a:solidFill>
+                          <a:latin typeface="맑은 고딕"/>
+                        </a:rPr>
+                        <a:t>원 제작</a:t>
+                      </a:r>
+                    </a:p>
+                  </a:txBody>
+                  <a:tcPr>
+                    <a:solidFill>
+                      <a:srgbClr val="F2ECDD"/>
+                    </a:solidFill>
+                  </a:tcPr>
+                </a:tc>
+                <a:tc>
+                  <a:txBody>
+                    <a:bodyPr/>
+                    <a:lstStyle/>
+                    <a:p>
+                      <a:r>
+                        <a:rPr sz="1300" b="0">
+                          <a:solidFill>
+                            <a:srgbClr val="211D18"/>
+                          </a:solidFill>
+                          <a:latin typeface="맑은 고딕"/>
+                        </a:rPr>
+                        <a:t>미 해군(U.S. Navy) — 타이틀 카드 판독 ①·②</a:t>
+                      </a:r>
+                    </a:p>
+                  </a:txBody>
+                  <a:tcPr>
+                    <a:solidFill>
+                      <a:srgbClr val="FFFDF7"/>
+                    </a:solidFill>
+                  </a:tcPr>
+                </a:tc>
+              </a:tr>
+              <a:tr h="475488">
+                <a:tc>
+                  <a:txBody>
+                    <a:bodyPr/>
+                    <a:lstStyle/>
+                    <a:p>
+                      <a:r>
+                        <a:rPr sz="1300" b="1">
+                          <a:solidFill>
+                            <a:srgbClr val="8A3033"/>
+                          </a:solidFill>
+                          <a:latin typeface="맑은 고딕"/>
+                        </a:rPr>
+                        <a:t>사본 소재</a:t>
+                      </a:r>
+                    </a:p>
+                  </a:txBody>
+                  <a:tcPr>
+                    <a:solidFill>
+                      <a:srgbClr val="F2ECDD"/>
+                    </a:solidFill>
+                  </a:tcPr>
+                </a:tc>
+                <a:tc>
+                  <a:txBody>
+                    <a:bodyPr/>
+                    <a:lstStyle/>
+                    <a:p>
+                      <a:r>
+                        <a:rPr sz="1300" b="0">
+                          <a:solidFill>
+                            <a:srgbClr val="211D18"/>
+                          </a:solidFill>
+                          <a:latin typeface="맑은 고딕"/>
+                        </a:rPr>
+                        <a:t>Internet Archive — Periscope Film 디지털화본</a:t>
+                      </a:r>
+                    </a:p>
+                  </a:txBody>
+                  <a:tcPr>
+                    <a:solidFill>
+                      <a:srgbClr val="FFFDF7"/>
+                    </a:solidFill>
+                  </a:tcPr>
+                </a:tc>
+              </a:tr>
+              <a:tr h="475488">
+                <a:tc>
+                  <a:txBody>
+                    <a:bodyPr/>
+                    <a:lstStyle/>
+                    <a:p>
+                      <a:r>
+                        <a:rPr sz="1300" b="1">
+                          <a:solidFill>
+                            <a:srgbClr val="8A3033"/>
+                          </a:solidFill>
+                          <a:latin typeface="맑은 고딕"/>
+                        </a:rPr>
+                        <a:t>생산시기</a:t>
+                      </a:r>
+                    </a:p>
+                  </a:txBody>
+                  <a:tcPr>
+                    <a:solidFill>
+                      <a:srgbClr val="F2ECDD"/>
+                    </a:solidFill>
+                  </a:tcPr>
+                </a:tc>
+                <a:tc>
+                  <a:txBody>
+                    <a:bodyPr/>
+                    <a:lstStyle/>
+                    <a:p>
+                      <a:r>
+                        <a:rPr sz="1300" b="0">
+                          <a:solidFill>
+                            <a:srgbClr val="211D18"/>
+                          </a:solidFill>
+                          <a:latin typeface="맑은 고딕"/>
+                        </a:rPr>
+                        <a:t>1950년 12월 (장진호 철수 작전)</a:t>
+                      </a:r>
+                    </a:p>
+                  </a:txBody>
+                  <a:tcPr>
+                    <a:solidFill>
+                      <a:srgbClr val="FFFDF7"/>
+                    </a:solidFill>
+                  </a:tcPr>
+                </a:tc>
+              </a:tr>
+              <a:tr h="475488">
+                <a:tc>
+                  <a:txBody>
+                    <a:bodyPr/>
+                    <a:lstStyle/>
+                    <a:p>
+                      <a:r>
+                        <a:rPr sz="1300" b="1">
+                          <a:solidFill>
+                            <a:srgbClr val="8A3033"/>
+                          </a:solidFill>
+                          <a:latin typeface="맑은 고딕"/>
+                        </a:rPr>
+                        <a:t>권리</a:t>
+                      </a:r>
+                    </a:p>
+                  </a:txBody>
+                  <a:tcPr>
+                    <a:solidFill>
+                      <a:srgbClr val="F2ECDD"/>
+                    </a:solidFill>
+                  </a:tcPr>
+                </a:tc>
+                <a:tc>
+                  <a:txBody>
+                    <a:bodyPr/>
+                    <a:lstStyle/>
+                    <a:p>
+                      <a:r>
+                        <a:rPr sz="1300" b="0">
+                          <a:solidFill>
+                            <a:srgbClr val="211D18"/>
+                          </a:solidFill>
+                          <a:latin typeface="맑은 고딕"/>
+                        </a:rPr>
+                        <a:t>원판 미 연방정부 저작물(PD) · 디지털화본 업체 워터마크 표시</a:t>
+                      </a:r>
+                    </a:p>
+                  </a:txBody>
+                  <a:tcPr>
+                    <a:solidFill>
+                      <a:srgbClr val="FFFDF7"/>
+                    </a:solidFill>
+                  </a:tcPr>
+                </a:tc>
+              </a:tr>
+            </a:tbl>
+          </a:graphicData>
+        </a:graphic>
+      </p:graphicFrame>
+      <p:pic>
+        <p:nvPicPr>
+          <p:cNvPr id="5" name="Picture 4" descr="doc_01_c.jpg"/>
+          <p:cNvPicPr>
+            <a:picLocks noChangeAspect="1"/>
+          </p:cNvPicPr>
+          <p:nvPr/>
+        </p:nvPicPr>
+        <p:blipFill>
+          <a:blip r:embed="rId2"/>
+          <a:stretch>
+            <a:fillRect/>
+          </a:stretch>
+        </p:blipFill>
+        <p:spPr>
+          <a:xfrm>
+            <a:off x="8778240" y="1691640"/>
+            <a:ext cx="2926080" cy="2199978"/>
+          </a:xfrm>
+          <a:prstGeom prst="rect">
+            <a:avLst/>
+          </a:prstGeom>
+        </p:spPr>
+      </p:pic>
+      <p:sp>
+        <p:nvSpPr>
+          <p:cNvPr id="6" name="TextBox 5"/>
+          <p:cNvSpPr txBox="1"/>
+          <p:nvPr/>
+        </p:nvSpPr>
+        <p:spPr>
+          <a:xfrm>
+            <a:off x="502920" y="5120640"/>
+            <a:ext cx="10972800" cy="731520"/>
+          </a:xfrm>
+          <a:prstGeom prst="rect">
+            <a:avLst/>
+          </a:prstGeom>
+          <a:noFill/>
+        </p:spPr>
+        <p:txBody>
+          <a:bodyPr wrap="square">
+            <a:spAutoFit/>
+          </a:bodyPr>
+          <a:lstStyle/>
+          <a:p>
+            <a:pPr algn="l">
+              <a:lnSpc>
+                <a:spcPct val="125000"/>
+              </a:lnSpc>
+            </a:pPr>
+            <a:r>
+              <a:rPr sz="1600" b="0">
+                <a:solidFill>
+                  <a:srgbClr val="211D18"/>
+                </a:solidFill>
+                <a:latin typeface="맑은 고딕"/>
+              </a:rPr>
+              <a:t>여섯 줄의 신원 — 전부 화면과 카탈로그에서 실확인한 것만 적었습니다.</a:t>
+            </a:r>
+          </a:p>
+        </p:txBody>
+      </p:sp>
+    </p:spTree>
+  </p:cSld>
+  <p:clrMapOvr>
+    <a:masterClrMapping/>
+  </p:clrMapOvr>
+</p:sld>
+</file>
+
+<file path=ppt/slides/slide3.xml><?xml version="1.0" encoding="utf-8"?>
+<p:sld xmlns:a="http://schemas.openxmlformats.org/drawingml/2006/main" xmlns:p="http://schemas.openxmlformats.org/presentationml/2006/main" xmlns:r="http://schemas.openxmlformats.org/officeDocument/2006/relationships">
+  <p:cSld>
+    <p:bg>
+      <p:bgPr>
+        <a:solidFill>
+          <a:srgbClr val="F5F1E8"/>
+        </a:solidFill>
+        <a:effectLst/>
+      </p:bgPr>
+    </p:bg>
+    <p:spTree>
+      <p:nvGrpSpPr>
+        <p:cNvPr id="1" name=""/>
+        <p:cNvGrpSpPr/>
+        <p:nvPr/>
+      </p:nvGrpSpPr>
+      <p:grpSpPr/>
+      <p:sp>
+        <p:nvSpPr>
+          <p:cNvPr id="2" name="TextBox 1"/>
+          <p:cNvSpPr txBox="1"/>
+          <p:nvPr/>
+        </p:nvSpPr>
+        <p:spPr>
+          <a:xfrm>
+            <a:off x="502920" y="365760"/>
+            <a:ext cx="10972800" cy="365760"/>
+          </a:xfrm>
+          <a:prstGeom prst="rect">
+            <a:avLst/>
+          </a:prstGeom>
+          <a:noFill/>
+        </p:spPr>
+        <p:txBody>
+          <a:bodyPr wrap="square">
+            <a:spAutoFit/>
+          </a:bodyPr>
+          <a:lstStyle/>
+          <a:p>
+            <a:pPr algn="l">
+              <a:lnSpc>
+                <a:spcPct val="125000"/>
+              </a:lnSpc>
+            </a:pPr>
+            <a:r>
+              <a:rPr sz="1300" b="1">
+                <a:solidFill>
+                  <a:srgbClr val="8A3033"/>
+                </a:solidFill>
+                <a:latin typeface="맑은 고딕"/>
+              </a:rPr>
+              <a:t>기록물 #1 — 판독</a:t>
+            </a:r>
+          </a:p>
+        </p:txBody>
+      </p:sp>
+      <p:sp>
+        <p:nvSpPr>
+          <p:cNvPr id="3" name="TextBox 2"/>
+          <p:cNvSpPr txBox="1"/>
+          <p:nvPr/>
+        </p:nvSpPr>
+        <p:spPr>
+          <a:xfrm>
+            <a:off x="502920" y="777240"/>
+            <a:ext cx="11155680" cy="640080"/>
+          </a:xfrm>
+          <a:prstGeom prst="rect">
+            <a:avLst/>
+          </a:prstGeom>
+          <a:noFill/>
+        </p:spPr>
+        <p:txBody>
+          <a:bodyPr wrap="square">
+            <a:spAutoFit/>
+          </a:bodyPr>
+          <a:lstStyle/>
+          <a:p>
+            <a:pPr algn="l">
+              <a:lnSpc>
+                <a:spcPct val="125000"/>
+              </a:lnSpc>
+            </a:pPr>
+            <a:r>
+              <a:rPr sz="2700" b="1">
+                <a:solidFill>
+                  <a:srgbClr val="211D18"/>
+                </a:solidFill>
+                <a:latin typeface="맑은 고딕"/>
+              </a:rPr>
+              <a:t>한 프레임, 네 가지 단서</a:t>
+            </a:r>
+          </a:p>
+        </p:txBody>
+      </p:sp>
+      <p:pic>
+        <p:nvPicPr>
+          <p:cNvPr id="4" name="Picture 3" descr="doc_01_c.jpg"/>
+          <p:cNvPicPr>
+            <a:picLocks noChangeAspect="1"/>
+          </p:cNvPicPr>
+          <p:nvPr/>
+        </p:nvPicPr>
+        <p:blipFill>
+          <a:blip r:embed="rId2"/>
+          <a:stretch>
+            <a:fillRect/>
+          </a:stretch>
+        </p:blipFill>
+        <p:spPr>
+          <a:xfrm>
+            <a:off x="502920" y="1645920"/>
+            <a:ext cx="6309360" cy="4743704"/>
+          </a:xfrm>
+          <a:prstGeom prst="rect">
+            <a:avLst/>
+          </a:prstGeom>
+        </p:spPr>
+      </p:pic>
+      <p:sp>
+        <p:nvSpPr>
+          <p:cNvPr id="5" name="Rounded Rectangle 4"/>
+          <p:cNvSpPr/>
+          <p:nvPr/>
+        </p:nvSpPr>
+        <p:spPr>
+          <a:xfrm>
+            <a:off x="629107" y="2025416"/>
+            <a:ext cx="2082088" cy="3130844"/>
+          </a:xfrm>
+          <a:prstGeom prst="roundRect">
+            <a:avLst>
+              <a:gd name="adj" fmla="val 6000"/>
+            </a:avLst>
+          </a:prstGeom>
+          <a:noFill/>
+          <a:ln w="19050">
+            <a:solidFill>
+              <a:srgbClr val="F8F4EA"/>
+            </a:solidFill>
+            <a:prstDash val="dash"/>
           </a:ln>
+          <a:effectLst/>
         </p:spPr>
         <p:style>
           <a:lnRef idx="1">
@@ -3940,688 +4658,24 @@
       </p:sp>
       <p:sp>
         <p:nvSpPr>
-          <p:cNvPr id="4" name="TextBox 3"/>
-          <p:cNvSpPr txBox="1"/>
+          <p:cNvPr id="6" name="Rounded Rectangle 5"/>
+          <p:cNvSpPr/>
           <p:nvPr/>
         </p:nvSpPr>
         <p:spPr>
           <a:xfrm>
-            <a:off x="548640" y="4480560"/>
-            <a:ext cx="10972800" cy="365760"/>
+            <a:off x="510235" y="1906544"/>
+            <a:ext cx="274320" cy="274320"/>
           </a:xfrm>
-          <a:prstGeom prst="rect">
-            <a:avLst/>
-          </a:prstGeom>
-          <a:noFill/>
-        </p:spPr>
-        <p:txBody>
-          <a:bodyPr wrap="square">
-            <a:spAutoFit/>
-          </a:bodyPr>
-          <a:lstStyle/>
-          <a:p>
-            <a:pPr algn="l">
-              <a:lnSpc>
-                <a:spcPct val="125000"/>
-              </a:lnSpc>
-            </a:pPr>
-            <a:r>
-              <a:rPr sz="1400" b="1">
-                <a:solidFill>
-                  <a:srgbClr val="C8A24A"/>
-                </a:solidFill>
-                <a:latin typeface="맑은 고딕"/>
-              </a:rPr>
-              <a:t>프레임 판독 — 기록 해설</a:t>
-            </a:r>
-          </a:p>
-        </p:txBody>
-      </p:sp>
-      <p:sp>
-        <p:nvSpPr>
-          <p:cNvPr id="5" name="TextBox 4"/>
-          <p:cNvSpPr txBox="1"/>
-          <p:nvPr/>
-        </p:nvSpPr>
-        <p:spPr>
-          <a:xfrm>
-            <a:off x="548640" y="4892040"/>
-            <a:ext cx="11155680" cy="1097280"/>
-          </a:xfrm>
-          <a:prstGeom prst="rect">
-            <a:avLst/>
-          </a:prstGeom>
-          <a:noFill/>
-        </p:spPr>
-        <p:txBody>
-          <a:bodyPr wrap="square">
-            <a:spAutoFit/>
-          </a:bodyPr>
-          <a:lstStyle/>
-          <a:p>
-            <a:pPr algn="l">
-              <a:lnSpc>
-                <a:spcPct val="125000"/>
-              </a:lnSpc>
-            </a:pPr>
-            <a:r>
-              <a:rPr sz="4000" b="1">
-                <a:solidFill>
-                  <a:srgbClr val="E9E2D6"/>
-                </a:solidFill>
-                <a:latin typeface="맑은 고딕"/>
-              </a:rPr>
-              <a:t>기록을 해설해 드립니다</a:t>
-            </a:r>
-          </a:p>
-        </p:txBody>
-      </p:sp>
-      <p:sp>
-        <p:nvSpPr>
-          <p:cNvPr id="6" name="TextBox 5"/>
-          <p:cNvSpPr txBox="1"/>
-          <p:nvPr/>
-        </p:nvSpPr>
-        <p:spPr>
-          <a:xfrm>
-            <a:off x="548640" y="5852160"/>
-            <a:ext cx="11155680" cy="457200"/>
-          </a:xfrm>
-          <a:prstGeom prst="rect">
-            <a:avLst/>
-          </a:prstGeom>
-          <a:noFill/>
-        </p:spPr>
-        <p:txBody>
-          <a:bodyPr wrap="square">
-            <a:spAutoFit/>
-          </a:bodyPr>
-          <a:lstStyle/>
-          <a:p>
-            <a:pPr algn="l">
-              <a:lnSpc>
-                <a:spcPct val="125000"/>
-              </a:lnSpc>
-            </a:pPr>
-            <a:r>
-              <a:rPr sz="1600" b="0">
-                <a:solidFill>
-                  <a:srgbClr val="9D9384"/>
-                </a:solidFill>
-                <a:latin typeface="맑은 고딕"/>
-              </a:rPr>
-              <a:t>한 프레임에서 제작 주체·판본·권리·좌표를 읽는 법</a:t>
-            </a:r>
-          </a:p>
-        </p:txBody>
-      </p:sp>
-    </p:spTree>
-  </p:cSld>
-  <p:clrMapOvr>
-    <a:masterClrMapping/>
-  </p:clrMapOvr>
-</p:sld>
-</file>
-
-<file path=ppt/slides/slide2.xml><?xml version="1.0" encoding="utf-8"?>
-<p:sld xmlns:a="http://schemas.openxmlformats.org/drawingml/2006/main" xmlns:p="http://schemas.openxmlformats.org/presentationml/2006/main" xmlns:r="http://schemas.openxmlformats.org/officeDocument/2006/relationships">
-  <p:cSld>
-    <p:bg>
-      <p:bgPr>
-        <a:solidFill>
-          <a:srgbClr val="F5EFE4"/>
-        </a:solidFill>
-        <a:effectLst/>
-      </p:bgPr>
-    </p:bg>
-    <p:spTree>
-      <p:nvGrpSpPr>
-        <p:cNvPr id="1" name=""/>
-        <p:cNvGrpSpPr/>
-        <p:nvPr/>
-      </p:nvGrpSpPr>
-      <p:grpSpPr/>
-      <p:sp>
-        <p:nvSpPr>
-          <p:cNvPr id="2" name="TextBox 1"/>
-          <p:cNvSpPr txBox="1"/>
-          <p:nvPr/>
-        </p:nvSpPr>
-        <p:spPr>
-          <a:xfrm>
-            <a:off x="502920" y="365760"/>
-            <a:ext cx="10972800" cy="365760"/>
-          </a:xfrm>
-          <a:prstGeom prst="rect">
-            <a:avLst/>
-          </a:prstGeom>
-          <a:noFill/>
-        </p:spPr>
-        <p:txBody>
-          <a:bodyPr wrap="square">
-            <a:spAutoFit/>
-          </a:bodyPr>
-          <a:lstStyle/>
-          <a:p>
-            <a:pPr algn="l">
-              <a:lnSpc>
-                <a:spcPct val="125000"/>
-              </a:lnSpc>
-            </a:pPr>
-            <a:r>
-              <a:rPr sz="1300" b="1">
-                <a:solidFill>
-                  <a:srgbClr val="B23A2E"/>
-                </a:solidFill>
-                <a:latin typeface="맑은 고딕"/>
-              </a:rPr>
-              <a:t>기록물 #1 — 기본 정보</a:t>
-            </a:r>
-          </a:p>
-        </p:txBody>
-      </p:sp>
-      <p:sp>
-        <p:nvSpPr>
-          <p:cNvPr id="3" name="TextBox 2"/>
-          <p:cNvSpPr txBox="1"/>
-          <p:nvPr/>
-        </p:nvSpPr>
-        <p:spPr>
-          <a:xfrm>
-            <a:off x="502920" y="777240"/>
-            <a:ext cx="11155680" cy="640080"/>
-          </a:xfrm>
-          <a:prstGeom prst="rect">
-            <a:avLst/>
-          </a:prstGeom>
-          <a:noFill/>
-        </p:spPr>
-        <p:txBody>
-          <a:bodyPr wrap="square">
-            <a:spAutoFit/>
-          </a:bodyPr>
-          <a:lstStyle/>
-          <a:p>
-            <a:pPr algn="l">
-              <a:lnSpc>
-                <a:spcPct val="125000"/>
-              </a:lnSpc>
-            </a:pPr>
-            <a:r>
-              <a:rPr sz="2800" b="1">
-                <a:solidFill>
-                  <a:srgbClr val="241D15"/>
-                </a:solidFill>
-                <a:latin typeface="맑은 고딕"/>
-              </a:rPr>
-              <a:t>이 필름의 신원</a:t>
-            </a:r>
-          </a:p>
-        </p:txBody>
-      </p:sp>
-      <p:graphicFrame>
-        <p:nvGraphicFramePr>
-          <p:cNvPr id="4" name="Table 3"/>
-          <p:cNvGraphicFramePr>
-            <a:graphicFrameLocks noGrp="1"/>
-          </p:cNvGraphicFramePr>
-          <p:nvPr/>
-        </p:nvGraphicFramePr>
-        <p:xfrm>
-          <a:off x="502920" y="1691640"/>
-          <a:ext cx="7863840" cy="2743200"/>
-        </p:xfrm>
-        <a:graphic>
-          <a:graphicData uri="http://schemas.openxmlformats.org/drawingml/2006/table">
-            <a:tbl>
-              <a:tblPr firstRow="1" bandRow="1">
-                <a:tableStyleId>{5C22544A-7EE6-4342-B048-85BDC9FD1C3A}</a:tableStyleId>
-              </a:tblPr>
-              <a:tblGrid>
-                <a:gridCol w="1645920"/>
-                <a:gridCol w="6217920"/>
-              </a:tblGrid>
-              <a:tr h="457200">
-                <a:tc>
-                  <a:txBody>
-                    <a:bodyPr/>
-                    <a:lstStyle/>
-                    <a:p>
-                      <a:r>
-                        <a:rPr sz="1300" b="1">
-                          <a:solidFill>
-                            <a:srgbClr val="241D15"/>
-                          </a:solidFill>
-                          <a:latin typeface="맑은 고딕"/>
-                        </a:rPr>
-                        <a:t>제목</a:t>
-                      </a:r>
-                    </a:p>
-                  </a:txBody>
-                  <a:tcPr/>
-                </a:tc>
-                <a:tc>
-                  <a:txBody>
-                    <a:bodyPr/>
-                    <a:lstStyle/>
-                    <a:p>
-                      <a:r>
-                        <a:rPr sz="1300" b="0">
-                          <a:solidFill>
-                            <a:srgbClr val="241D15"/>
-                          </a:solidFill>
-                          <a:latin typeface="맑은 고딕"/>
-                        </a:rPr>
-                        <a:t>Chosin to Hungnam (장진호에서 흥남으로)</a:t>
-                      </a:r>
-                    </a:p>
-                  </a:txBody>
-                  <a:tcPr/>
-                </a:tc>
-              </a:tr>
-              <a:tr h="457200">
-                <a:tc>
-                  <a:txBody>
-                    <a:bodyPr/>
-                    <a:lstStyle/>
-                    <a:p>
-                      <a:r>
-                        <a:rPr sz="1300" b="1">
-                          <a:solidFill>
-                            <a:srgbClr val="241D15"/>
-                          </a:solidFill>
-                          <a:latin typeface="맑은 고딕"/>
-                        </a:rPr>
-                        <a:t>식별번호</a:t>
-                      </a:r>
-                    </a:p>
-                  </a:txBody>
-                  <a:tcPr/>
-                </a:tc>
-                <a:tc>
-                  <a:txBody>
-                    <a:bodyPr/>
-                    <a:lstStyle/>
-                    <a:p>
-                      <a:r>
-                        <a:rPr sz="1300" b="0">
-                          <a:solidFill>
-                            <a:srgbClr val="241D15"/>
-                          </a:solidFill>
-                          <a:latin typeface="맑은 고딕"/>
-                        </a:rPr>
-                        <a:t>archive.org 81594 · PF# 81594</a:t>
-                      </a:r>
-                    </a:p>
-                  </a:txBody>
-                  <a:tcPr/>
-                </a:tc>
-              </a:tr>
-              <a:tr h="457200">
-                <a:tc>
-                  <a:txBody>
-                    <a:bodyPr/>
-                    <a:lstStyle/>
-                    <a:p>
-                      <a:r>
-                        <a:rPr sz="1300" b="1">
-                          <a:solidFill>
-                            <a:srgbClr val="241D15"/>
-                          </a:solidFill>
-                          <a:latin typeface="맑은 고딕"/>
-                        </a:rPr>
-                        <a:t>원 제작</a:t>
-                      </a:r>
-                    </a:p>
-                  </a:txBody>
-                  <a:tcPr/>
-                </a:tc>
-                <a:tc>
-                  <a:txBody>
-                    <a:bodyPr/>
-                    <a:lstStyle/>
-                    <a:p>
-                      <a:r>
-                        <a:rPr sz="1300" b="0">
-                          <a:solidFill>
-                            <a:srgbClr val="241D15"/>
-                          </a:solidFill>
-                          <a:latin typeface="맑은 고딕"/>
-                        </a:rPr>
-                        <a:t>미 해군(U.S. Navy) — 타이틀 카드 판독 ①·②</a:t>
-                      </a:r>
-                    </a:p>
-                  </a:txBody>
-                  <a:tcPr/>
-                </a:tc>
-              </a:tr>
-              <a:tr h="457200">
-                <a:tc>
-                  <a:txBody>
-                    <a:bodyPr/>
-                    <a:lstStyle/>
-                    <a:p>
-                      <a:r>
-                        <a:rPr sz="1300" b="1">
-                          <a:solidFill>
-                            <a:srgbClr val="241D15"/>
-                          </a:solidFill>
-                          <a:latin typeface="맑은 고딕"/>
-                        </a:rPr>
-                        <a:t>사본 소재</a:t>
-                      </a:r>
-                    </a:p>
-                  </a:txBody>
-                  <a:tcPr/>
-                </a:tc>
-                <a:tc>
-                  <a:txBody>
-                    <a:bodyPr/>
-                    <a:lstStyle/>
-                    <a:p>
-                      <a:r>
-                        <a:rPr sz="1300" b="0">
-                          <a:solidFill>
-                            <a:srgbClr val="241D15"/>
-                          </a:solidFill>
-                          <a:latin typeface="맑은 고딕"/>
-                        </a:rPr>
-                        <a:t>Internet Archive — Periscope Film 디지털화본</a:t>
-                      </a:r>
-                    </a:p>
-                  </a:txBody>
-                  <a:tcPr/>
-                </a:tc>
-              </a:tr>
-              <a:tr h="457200">
-                <a:tc>
-                  <a:txBody>
-                    <a:bodyPr/>
-                    <a:lstStyle/>
-                    <a:p>
-                      <a:r>
-                        <a:rPr sz="1300" b="1">
-                          <a:solidFill>
-                            <a:srgbClr val="241D15"/>
-                          </a:solidFill>
-                          <a:latin typeface="맑은 고딕"/>
-                        </a:rPr>
-                        <a:t>생산시기</a:t>
-                      </a:r>
-                    </a:p>
-                  </a:txBody>
-                  <a:tcPr/>
-                </a:tc>
-                <a:tc>
-                  <a:txBody>
-                    <a:bodyPr/>
-                    <a:lstStyle/>
-                    <a:p>
-                      <a:r>
-                        <a:rPr sz="1300" b="0">
-                          <a:solidFill>
-                            <a:srgbClr val="241D15"/>
-                          </a:solidFill>
-                          <a:latin typeface="맑은 고딕"/>
-                        </a:rPr>
-                        <a:t>1950년 12월 (장진호 철수 작전)</a:t>
-                      </a:r>
-                    </a:p>
-                  </a:txBody>
-                  <a:tcPr/>
-                </a:tc>
-              </a:tr>
-              <a:tr h="457200">
-                <a:tc>
-                  <a:txBody>
-                    <a:bodyPr/>
-                    <a:lstStyle/>
-                    <a:p>
-                      <a:r>
-                        <a:rPr sz="1300" b="1">
-                          <a:solidFill>
-                            <a:srgbClr val="241D15"/>
-                          </a:solidFill>
-                          <a:latin typeface="맑은 고딕"/>
-                        </a:rPr>
-                        <a:t>권리</a:t>
-                      </a:r>
-                    </a:p>
-                  </a:txBody>
-                  <a:tcPr/>
-                </a:tc>
-                <a:tc>
-                  <a:txBody>
-                    <a:bodyPr/>
-                    <a:lstStyle/>
-                    <a:p>
-                      <a:r>
-                        <a:rPr sz="1300" b="0">
-                          <a:solidFill>
-                            <a:srgbClr val="241D15"/>
-                          </a:solidFill>
-                          <a:latin typeface="맑은 고딕"/>
-                        </a:rPr>
-                        <a:t>원판 미 연방정부 저작물(PD) · 디지털화본 업체 워터마크 표시</a:t>
-                      </a:r>
-                    </a:p>
-                  </a:txBody>
-                  <a:tcPr/>
-                </a:tc>
-              </a:tr>
-            </a:tbl>
-          </a:graphicData>
-        </a:graphic>
-      </p:graphicFrame>
-      <p:pic>
-        <p:nvPicPr>
-          <p:cNvPr id="5" name="Picture 4" descr="doc_01.jpg"/>
-          <p:cNvPicPr>
-            <a:picLocks noChangeAspect="1"/>
-          </p:cNvPicPr>
-          <p:nvPr/>
-        </p:nvPicPr>
-        <p:blipFill>
-          <a:blip r:embed="rId2"/>
-          <a:stretch>
-            <a:fillRect/>
-          </a:stretch>
-        </p:blipFill>
-        <p:spPr>
-          <a:xfrm>
-            <a:off x="8778240" y="1691640"/>
-            <a:ext cx="2926080" cy="2194560"/>
-          </a:xfrm>
-          <a:prstGeom prst="rect">
-            <a:avLst/>
-          </a:prstGeom>
-        </p:spPr>
-      </p:pic>
-      <p:sp>
-        <p:nvSpPr>
-          <p:cNvPr id="6" name="TextBox 5"/>
-          <p:cNvSpPr txBox="1"/>
-          <p:nvPr/>
-        </p:nvSpPr>
-        <p:spPr>
-          <a:xfrm>
-            <a:off x="502920" y="5120640"/>
-            <a:ext cx="10972800" cy="731520"/>
-          </a:xfrm>
-          <a:prstGeom prst="rect">
-            <a:avLst/>
-          </a:prstGeom>
-          <a:noFill/>
-        </p:spPr>
-        <p:txBody>
-          <a:bodyPr wrap="square">
-            <a:spAutoFit/>
-          </a:bodyPr>
-          <a:lstStyle/>
-          <a:p>
-            <a:pPr algn="l">
-              <a:lnSpc>
-                <a:spcPct val="125000"/>
-              </a:lnSpc>
-            </a:pPr>
-            <a:r>
-              <a:rPr sz="1600" b="0">
-                <a:solidFill>
-                  <a:srgbClr val="241D15"/>
-                </a:solidFill>
-                <a:latin typeface="맑은 고딕"/>
-              </a:rPr>
-              <a:t>여섯 줄의 신원 — 전부 화면과 카탈로그에서 실확인한 것만 적었습니다.</a:t>
-            </a:r>
-          </a:p>
-        </p:txBody>
-      </p:sp>
-    </p:spTree>
-  </p:cSld>
-  <p:clrMapOvr>
-    <a:masterClrMapping/>
-  </p:clrMapOvr>
-</p:sld>
-</file>
-
-<file path=ppt/slides/slide3.xml><?xml version="1.0" encoding="utf-8"?>
-<p:sld xmlns:a="http://schemas.openxmlformats.org/drawingml/2006/main" xmlns:p="http://schemas.openxmlformats.org/presentationml/2006/main" xmlns:r="http://schemas.openxmlformats.org/officeDocument/2006/relationships">
-  <p:cSld>
-    <p:bg>
-      <p:bgPr>
-        <a:solidFill>
-          <a:srgbClr val="F5EFE4"/>
-        </a:solidFill>
-        <a:effectLst/>
-      </p:bgPr>
-    </p:bg>
-    <p:spTree>
-      <p:nvGrpSpPr>
-        <p:cNvPr id="1" name=""/>
-        <p:cNvGrpSpPr/>
-        <p:nvPr/>
-      </p:nvGrpSpPr>
-      <p:grpSpPr/>
-      <p:sp>
-        <p:nvSpPr>
-          <p:cNvPr id="2" name="TextBox 1"/>
-          <p:cNvSpPr txBox="1"/>
-          <p:nvPr/>
-        </p:nvSpPr>
-        <p:spPr>
-          <a:xfrm>
-            <a:off x="502920" y="365760"/>
-            <a:ext cx="10972800" cy="365760"/>
-          </a:xfrm>
-          <a:prstGeom prst="rect">
-            <a:avLst/>
-          </a:prstGeom>
-          <a:noFill/>
-        </p:spPr>
-        <p:txBody>
-          <a:bodyPr wrap="square">
-            <a:spAutoFit/>
-          </a:bodyPr>
-          <a:lstStyle/>
-          <a:p>
-            <a:pPr algn="l">
-              <a:lnSpc>
-                <a:spcPct val="125000"/>
-              </a:lnSpc>
-            </a:pPr>
-            <a:r>
-              <a:rPr sz="1300" b="1">
-                <a:solidFill>
-                  <a:srgbClr val="B23A2E"/>
-                </a:solidFill>
-                <a:latin typeface="맑은 고딕"/>
-              </a:rPr>
-              <a:t>기록물 #1 — 판독</a:t>
-            </a:r>
-          </a:p>
-        </p:txBody>
-      </p:sp>
-      <p:sp>
-        <p:nvSpPr>
-          <p:cNvPr id="3" name="TextBox 2"/>
-          <p:cNvSpPr txBox="1"/>
-          <p:nvPr/>
-        </p:nvSpPr>
-        <p:spPr>
-          <a:xfrm>
-            <a:off x="502920" y="777240"/>
-            <a:ext cx="11155680" cy="640080"/>
-          </a:xfrm>
-          <a:prstGeom prst="rect">
-            <a:avLst/>
-          </a:prstGeom>
-          <a:noFill/>
-        </p:spPr>
-        <p:txBody>
-          <a:bodyPr wrap="square">
-            <a:spAutoFit/>
-          </a:bodyPr>
-          <a:lstStyle/>
-          <a:p>
-            <a:pPr algn="l">
-              <a:lnSpc>
-                <a:spcPct val="125000"/>
-              </a:lnSpc>
-            </a:pPr>
-            <a:r>
-              <a:rPr sz="2800" b="1">
-                <a:solidFill>
-                  <a:srgbClr val="241D15"/>
-                </a:solidFill>
-                <a:latin typeface="맑은 고딕"/>
-              </a:rPr>
-              <a:t>한 프레임, 네 가지 단서</a:t>
-            </a:r>
-          </a:p>
-        </p:txBody>
-      </p:sp>
-      <p:pic>
-        <p:nvPicPr>
-          <p:cNvPr id="4" name="Picture 3" descr="doc_01.jpg"/>
-          <p:cNvPicPr>
-            <a:picLocks noChangeAspect="1"/>
-          </p:cNvPicPr>
-          <p:nvPr/>
-        </p:nvPicPr>
-        <p:blipFill>
-          <a:blip r:embed="rId2"/>
-          <a:stretch>
-            <a:fillRect/>
-          </a:stretch>
-        </p:blipFill>
-        <p:spPr>
-          <a:xfrm>
-            <a:off x="502920" y="1645920"/>
-            <a:ext cx="6035040" cy="3403092"/>
-          </a:xfrm>
-          <a:prstGeom prst="rect">
-            <a:avLst/>
-          </a:prstGeom>
-        </p:spPr>
-      </p:pic>
-      <p:sp>
-        <p:nvSpPr>
-          <p:cNvPr id="5" name="Oval 4"/>
-          <p:cNvSpPr/>
-          <p:nvPr/>
-        </p:nvSpPr>
-        <p:spPr>
-          <a:xfrm>
-            <a:off x="1605686" y="2298070"/>
-            <a:ext cx="329184" cy="329184"/>
-          </a:xfrm>
-          <a:prstGeom prst="ellipse">
-            <a:avLst/>
+          <a:prstGeom prst="roundRect">
+            <a:avLst>
+              <a:gd name="adj" fmla="val 25000"/>
+            </a:avLst>
           </a:prstGeom>
           <a:solidFill>
-            <a:srgbClr val="B23A2E"/>
+            <a:srgbClr val="8A3033"/>
           </a:solidFill>
-          <a:ln w="25400">
+          <a:ln w="12700">
             <a:solidFill>
               <a:srgbClr val="FFFFFF"/>
             </a:solidFill>
@@ -4642,12 +4696,12 @@
           </a:fontRef>
         </p:style>
         <p:txBody>
-          <a:bodyPr rtlCol="0" anchor="ctr" wrap="none"/>
+          <a:bodyPr rtlCol="0" anchor="ctr" lIns="0" rIns="0" tIns="0" bIns="0"/>
           <a:lstStyle/>
           <a:p>
             <a:pPr algn="ctr"/>
             <a:r>
-              <a:rPr sz="1400" b="1">
+              <a:rPr sz="1200" b="1">
                 <a:solidFill>
                   <a:srgbClr val="FFFFFF"/>
                 </a:solidFill>
@@ -4659,22 +4713,71 @@
       </p:sp>
       <p:sp>
         <p:nvSpPr>
-          <p:cNvPr id="6" name="Oval 5"/>
+          <p:cNvPr id="7" name="Rounded Rectangle 6"/>
           <p:cNvSpPr/>
           <p:nvPr/>
         </p:nvSpPr>
         <p:spPr>
           <a:xfrm>
-            <a:off x="4140403" y="2842564"/>
-            <a:ext cx="329184" cy="329184"/>
+            <a:off x="2900476" y="1883105"/>
+            <a:ext cx="3722522" cy="2846222"/>
           </a:xfrm>
-          <a:prstGeom prst="ellipse">
-            <a:avLst/>
+          <a:prstGeom prst="roundRect">
+            <a:avLst>
+              <a:gd name="adj" fmla="val 6000"/>
+            </a:avLst>
+          </a:prstGeom>
+          <a:noFill/>
+          <a:ln w="19050">
+            <a:solidFill>
+              <a:srgbClr val="F8F4EA"/>
+            </a:solidFill>
+            <a:prstDash val="dash"/>
+          </a:ln>
+          <a:effectLst/>
+        </p:spPr>
+        <p:style>
+          <a:lnRef idx="1">
+            <a:schemeClr val="accent1"/>
+          </a:lnRef>
+          <a:fillRef idx="3">
+            <a:schemeClr val="accent1"/>
+          </a:fillRef>
+          <a:effectRef idx="2">
+            <a:schemeClr val="accent1"/>
+          </a:effectRef>
+          <a:fontRef idx="minor">
+            <a:schemeClr val="lt1"/>
+          </a:fontRef>
+        </p:style>
+        <p:txBody>
+          <a:bodyPr rtlCol="0" anchor="ctr"/>
+          <a:lstStyle/>
+          <a:p>
+            <a:pPr algn="ctr"/>
+          </a:p>
+        </p:txBody>
+      </p:sp>
+      <p:sp>
+        <p:nvSpPr>
+          <p:cNvPr id="8" name="Rounded Rectangle 7"/>
+          <p:cNvSpPr/>
+          <p:nvPr/>
+        </p:nvSpPr>
+        <p:spPr>
+          <a:xfrm>
+            <a:off x="2781604" y="1764233"/>
+            <a:ext cx="274320" cy="274320"/>
+          </a:xfrm>
+          <a:prstGeom prst="roundRect">
+            <a:avLst>
+              <a:gd name="adj" fmla="val 25000"/>
+            </a:avLst>
           </a:prstGeom>
           <a:solidFill>
-            <a:srgbClr val="B23A2E"/>
+            <a:srgbClr val="8A3033"/>
           </a:solidFill>
-          <a:ln w="25400">
+          <a:ln w="12700">
             <a:solidFill>
               <a:srgbClr val="FFFFFF"/>
             </a:solidFill>
@@ -4695,12 +4798,12 @@
           </a:fontRef>
         </p:style>
         <p:txBody>
-          <a:bodyPr rtlCol="0" anchor="ctr" wrap="none"/>
+          <a:bodyPr rtlCol="0" anchor="ctr" lIns="0" rIns="0" tIns="0" bIns="0"/>
           <a:lstStyle/>
           <a:p>
             <a:pPr algn="ctr"/>
             <a:r>
-              <a:rPr sz="1400" b="1">
+              <a:rPr sz="1200" b="1">
                 <a:solidFill>
                   <a:srgbClr val="FFFFFF"/>
                 </a:solidFill>
@@ -4712,22 +4815,71 @@
       </p:sp>
       <p:sp>
         <p:nvSpPr>
-          <p:cNvPr id="7" name="Oval 6"/>
+          <p:cNvPr id="9" name="Rounded Rectangle 8"/>
           <p:cNvSpPr/>
           <p:nvPr/>
         </p:nvSpPr>
         <p:spPr>
           <a:xfrm>
-            <a:off x="3355847" y="4135739"/>
-            <a:ext cx="329184" cy="329184"/>
+            <a:off x="1827885" y="5108823"/>
+            <a:ext cx="3659428" cy="521807"/>
           </a:xfrm>
-          <a:prstGeom prst="ellipse">
-            <a:avLst/>
+          <a:prstGeom prst="roundRect">
+            <a:avLst>
+              <a:gd name="adj" fmla="val 6000"/>
+            </a:avLst>
+          </a:prstGeom>
+          <a:noFill/>
+          <a:ln w="19050">
+            <a:solidFill>
+              <a:srgbClr val="F8F4EA"/>
+            </a:solidFill>
+            <a:prstDash val="dash"/>
+          </a:ln>
+          <a:effectLst/>
+        </p:spPr>
+        <p:style>
+          <a:lnRef idx="1">
+            <a:schemeClr val="accent1"/>
+          </a:lnRef>
+          <a:fillRef idx="3">
+            <a:schemeClr val="accent1"/>
+          </a:fillRef>
+          <a:effectRef idx="2">
+            <a:schemeClr val="accent1"/>
+          </a:effectRef>
+          <a:fontRef idx="minor">
+            <a:schemeClr val="lt1"/>
+          </a:fontRef>
+        </p:style>
+        <p:txBody>
+          <a:bodyPr rtlCol="0" anchor="ctr"/>
+          <a:lstStyle/>
+          <a:p>
+            <a:pPr algn="ctr"/>
+          </a:p>
+        </p:txBody>
+      </p:sp>
+      <p:sp>
+        <p:nvSpPr>
+          <p:cNvPr id="10" name="Rounded Rectangle 9"/>
+          <p:cNvSpPr/>
+          <p:nvPr/>
+        </p:nvSpPr>
+        <p:spPr>
+          <a:xfrm>
+            <a:off x="1709013" y="4989951"/>
+            <a:ext cx="274320" cy="274320"/>
+          </a:xfrm>
+          <a:prstGeom prst="roundRect">
+            <a:avLst>
+              <a:gd name="adj" fmla="val 25000"/>
+            </a:avLst>
           </a:prstGeom>
           <a:solidFill>
-            <a:srgbClr val="B23A2E"/>
+            <a:srgbClr val="8A3033"/>
           </a:solidFill>
-          <a:ln w="25400">
+          <a:ln w="12700">
             <a:solidFill>
               <a:srgbClr val="FFFFFF"/>
             </a:solidFill>
@@ -4748,12 +4900,12 @@
           </a:fontRef>
         </p:style>
         <p:txBody>
-          <a:bodyPr rtlCol="0" anchor="ctr" wrap="none"/>
+          <a:bodyPr rtlCol="0" anchor="ctr" lIns="0" rIns="0" tIns="0" bIns="0"/>
           <a:lstStyle/>
           <a:p>
             <a:pPr algn="ctr"/>
             <a:r>
-              <a:rPr sz="1400" b="1">
+              <a:rPr sz="1200" b="1">
                 <a:solidFill>
                   <a:srgbClr val="FFFFFF"/>
                 </a:solidFill>
@@ -4765,22 +4917,71 @@
       </p:sp>
       <p:sp>
         <p:nvSpPr>
-          <p:cNvPr id="8" name="Oval 7"/>
+          <p:cNvPr id="11" name="Rounded Rectangle 10"/>
           <p:cNvSpPr/>
           <p:nvPr/>
         </p:nvSpPr>
         <p:spPr>
           <a:xfrm>
-            <a:off x="3355847" y="4476048"/>
-            <a:ext cx="329184" cy="329184"/>
+            <a:off x="2143353" y="5678068"/>
+            <a:ext cx="3028492" cy="474370"/>
           </a:xfrm>
-          <a:prstGeom prst="ellipse">
-            <a:avLst/>
+          <a:prstGeom prst="roundRect">
+            <a:avLst>
+              <a:gd name="adj" fmla="val 6000"/>
+            </a:avLst>
+          </a:prstGeom>
+          <a:noFill/>
+          <a:ln w="19050">
+            <a:solidFill>
+              <a:srgbClr val="F8F4EA"/>
+            </a:solidFill>
+            <a:prstDash val="dash"/>
+          </a:ln>
+          <a:effectLst/>
+        </p:spPr>
+        <p:style>
+          <a:lnRef idx="1">
+            <a:schemeClr val="accent1"/>
+          </a:lnRef>
+          <a:fillRef idx="3">
+            <a:schemeClr val="accent1"/>
+          </a:fillRef>
+          <a:effectRef idx="2">
+            <a:schemeClr val="accent1"/>
+          </a:effectRef>
+          <a:fontRef idx="minor">
+            <a:schemeClr val="lt1"/>
+          </a:fontRef>
+        </p:style>
+        <p:txBody>
+          <a:bodyPr rtlCol="0" anchor="ctr"/>
+          <a:lstStyle/>
+          <a:p>
+            <a:pPr algn="ctr"/>
+          </a:p>
+        </p:txBody>
+      </p:sp>
+      <p:sp>
+        <p:nvSpPr>
+          <p:cNvPr id="12" name="Rounded Rectangle 11"/>
+          <p:cNvSpPr/>
+          <p:nvPr/>
+        </p:nvSpPr>
+        <p:spPr>
+          <a:xfrm>
+            <a:off x="2024481" y="5559196"/>
+            <a:ext cx="274320" cy="274320"/>
+          </a:xfrm>
+          <a:prstGeom prst="roundRect">
+            <a:avLst>
+              <a:gd name="adj" fmla="val 25000"/>
+            </a:avLst>
           </a:prstGeom>
           <a:solidFill>
-            <a:srgbClr val="B23A2E"/>
+            <a:srgbClr val="8A3033"/>
           </a:solidFill>
-          <a:ln w="25400">
+          <a:ln w="12700">
             <a:solidFill>
               <a:srgbClr val="FFFFFF"/>
             </a:solidFill>
@@ -4801,12 +5002,12 @@
           </a:fontRef>
         </p:style>
         <p:txBody>
-          <a:bodyPr rtlCol="0" anchor="ctr" wrap="none"/>
+          <a:bodyPr rtlCol="0" anchor="ctr" lIns="0" rIns="0" tIns="0" bIns="0"/>
           <a:lstStyle/>
           <a:p>
             <a:pPr algn="ctr"/>
             <a:r>
-              <a:rPr sz="1400" b="1">
+              <a:rPr sz="1200" b="1">
                 <a:solidFill>
                   <a:srgbClr val="FFFFFF"/>
                 </a:solidFill>
@@ -4818,14 +5019,14 @@
       </p:sp>
       <p:sp>
         <p:nvSpPr>
-          <p:cNvPr id="9" name="TextBox 8"/>
+          <p:cNvPr id="13" name="TextBox 12"/>
           <p:cNvSpPr txBox="1"/>
           <p:nvPr/>
         </p:nvSpPr>
         <p:spPr>
           <a:xfrm>
-            <a:off x="6858000" y="1737360"/>
-            <a:ext cx="4846320" cy="4206240"/>
+            <a:off x="7132320" y="1737360"/>
+            <a:ext cx="4572000" cy="4206240"/>
           </a:xfrm>
           <a:prstGeom prst="rect">
             <a:avLst/>
@@ -4844,13 +5045,13 @@
               </a:lnSpc>
             </a:pPr>
             <a:r>
-              <a:rPr sz="1300" b="0">
+              <a:rPr sz="1250" b="0">
                 <a:solidFill>
-                  <a:srgbClr val="241D15"/>
+                  <a:srgbClr val="211D18"/>
                 </a:solidFill>
                 <a:latin typeface="맑은 고딕"/>
               </a:rPr>
-              <a:t>1  미 해군부 인장 — ‘NAVY DEPARTMENT · UNITED STATES OF AMERICA’. 제작 주체가 화면에 남긴 공식 표식.</a:t>
+              <a:t>1   미 해군부 인장 — ‘NAVY DEPARTMENT · UNITED STATES OF AMERICA’. 제작 주체의 공식 표식.</a:t>
             </a:r>
           </a:p>
           <a:p>
@@ -4860,13 +5061,13 @@
               </a:lnSpc>
             </a:pPr>
             <a:r>
-              <a:rPr sz="1300" b="0">
+              <a:rPr sz="500" b="0">
                 <a:solidFill>
-                  <a:srgbClr val="241D15"/>
+                  <a:srgbClr val="211D18"/>
                 </a:solidFill>
                 <a:latin typeface="맑은 고딕"/>
               </a:rPr>
-              <a:t>2  ‘The United States Navy Presents’ — 미 해군 공식 제작물임을 밝히는 오프닝 타이틀.</a:t>
+              <a:t/>
             </a:r>
           </a:p>
           <a:p>
@@ -4876,13 +5077,13 @@
               </a:lnSpc>
             </a:pPr>
             <a:r>
-              <a:rPr sz="1300" b="0">
+              <a:rPr sz="1250" b="0">
                 <a:solidFill>
-                  <a:srgbClr val="241D15"/>
+                  <a:srgbClr val="211D18"/>
                 </a:solidFill>
                 <a:latin typeface="맑은 고딕"/>
               </a:rPr>
-              <a:t>3  ‘PF# 81594 00:00:58:02’ — 디지털화 업체 카탈로그 번호와 타임코드. 인용 시 장면 좌표가 된다.</a:t>
+              <a:t>2   ‘The United States Navy Presents’ — 미 해군 공식 제작물임을 밝히는 오프닝 타이틀.</a:t>
             </a:r>
           </a:p>
           <a:p>
@@ -4892,20 +5093,84 @@
               </a:lnSpc>
             </a:pPr>
             <a:r>
-              <a:rPr sz="1300" b="0">
+              <a:rPr sz="500" b="0">
                 <a:solidFill>
-                  <a:srgbClr val="241D15"/>
+                  <a:srgbClr val="211D18"/>
                 </a:solidFill>
                 <a:latin typeface="맑은 고딕"/>
               </a:rPr>
-              <a:t>4  PeriscopeFilm.com 워터마크 — 원판(PD)과 달리 디지털화본에는 업체 표시가 있다. 사용 시 명기.</a:t>
-            </a:r>
-          </a:p>
-        </p:txBody>
-      </p:sp>
-      <p:sp>
-        <p:nvSpPr>
-          <p:cNvPr id="10" name="TextBox 9"/>
+              <a:t/>
+            </a:r>
+          </a:p>
+          <a:p>
+            <a:pPr algn="l">
+              <a:lnSpc>
+                <a:spcPct val="130000"/>
+              </a:lnSpc>
+            </a:pPr>
+            <a:r>
+              <a:rPr sz="1250" b="0">
+                <a:solidFill>
+                  <a:srgbClr val="211D18"/>
+                </a:solidFill>
+                <a:latin typeface="맑은 고딕"/>
+              </a:rPr>
+              <a:t>3   ‘PF# 81594 00:00:58:02’ — 디지털화 업체 카탈로그 번호·타임코드. 인용 좌표가 된다.</a:t>
+            </a:r>
+          </a:p>
+          <a:p>
+            <a:pPr algn="l">
+              <a:lnSpc>
+                <a:spcPct val="130000"/>
+              </a:lnSpc>
+            </a:pPr>
+            <a:r>
+              <a:rPr sz="500" b="0">
+                <a:solidFill>
+                  <a:srgbClr val="211D18"/>
+                </a:solidFill>
+                <a:latin typeface="맑은 고딕"/>
+              </a:rPr>
+              <a:t/>
+            </a:r>
+          </a:p>
+          <a:p>
+            <a:pPr algn="l">
+              <a:lnSpc>
+                <a:spcPct val="130000"/>
+              </a:lnSpc>
+            </a:pPr>
+            <a:r>
+              <a:rPr sz="1250" b="0">
+                <a:solidFill>
+                  <a:srgbClr val="211D18"/>
+                </a:solidFill>
+                <a:latin typeface="맑은 고딕"/>
+              </a:rPr>
+              <a:t>4   PeriscopeFilm.com 워터마크 — 원판(PD)과 달리 디지털화본에는 업체 표시가 있다.</a:t>
+            </a:r>
+          </a:p>
+          <a:p>
+            <a:pPr algn="l">
+              <a:lnSpc>
+                <a:spcPct val="130000"/>
+              </a:lnSpc>
+            </a:pPr>
+            <a:r>
+              <a:rPr sz="500" b="0">
+                <a:solidFill>
+                  <a:srgbClr val="211D18"/>
+                </a:solidFill>
+                <a:latin typeface="맑은 고딕"/>
+              </a:rPr>
+              <a:t/>
+            </a:r>
+          </a:p>
+        </p:txBody>
+      </p:sp>
+      <p:sp>
+        <p:nvSpPr>
+          <p:cNvPr id="14" name="TextBox 13"/>
           <p:cNvSpPr txBox="1"/>
           <p:nvPr/>
         </p:nvSpPr>
@@ -5163,7 +5428,7 @@
     <p:bg>
       <p:bgPr>
         <a:solidFill>
-          <a:srgbClr val="F5EFE4"/>
+          <a:srgbClr val="F5F1E8"/>
         </a:solidFill>
         <a:effectLst/>
       </p:bgPr>
@@ -5205,7 +5470,7 @@
             <a:r>
               <a:rPr sz="1300" b="1">
                 <a:solidFill>
-                  <a:srgbClr val="B23A2E"/>
+                  <a:srgbClr val="8A3033"/>
                 </a:solidFill>
                 <a:latin typeface="맑은 고딕"/>
               </a:rPr>
@@ -5242,9 +5507,9 @@
               </a:lnSpc>
             </a:pPr>
             <a:r>
-              <a:rPr sz="2800" b="1">
+              <a:rPr sz="2700" b="1">
                 <a:solidFill>
-                  <a:srgbClr val="241D15"/>
+                  <a:srgbClr val="211D18"/>
                 </a:solidFill>
                 <a:latin typeface="맑은 고딕"/>
               </a:rPr>
@@ -5255,7 +5520,7 @@
       </p:sp>
       <p:pic>
         <p:nvPicPr>
-          <p:cNvPr id="4" name="Picture 3" descr="doc_12.jpg"/>
+          <p:cNvPr id="4" name="Picture 3" descr="doc_12_c.jpg"/>
           <p:cNvPicPr>
             <a:picLocks noChangeAspect="1"/>
           </p:cNvPicPr>
@@ -5270,7 +5535,7 @@
         <p:spPr>
           <a:xfrm>
             <a:off x="502920" y="1645920"/>
-            <a:ext cx="6035040" cy="3403092"/>
+            <a:ext cx="6309360" cy="4743704"/>
           </a:xfrm>
           <a:prstGeom prst="rect">
             <a:avLst/>
@@ -5279,22 +5544,71 @@
       </p:pic>
       <p:sp>
         <p:nvSpPr>
-          <p:cNvPr id="5" name="Oval 4"/>
+          <p:cNvPr id="5" name="Rounded Rectangle 4"/>
           <p:cNvSpPr/>
           <p:nvPr/>
         </p:nvSpPr>
         <p:spPr>
           <a:xfrm>
-            <a:off x="4321454" y="3353028"/>
-            <a:ext cx="329184" cy="329184"/>
+            <a:off x="4036161" y="3733149"/>
+            <a:ext cx="1072591" cy="1328237"/>
           </a:xfrm>
-          <a:prstGeom prst="ellipse">
-            <a:avLst/>
+          <a:prstGeom prst="roundRect">
+            <a:avLst>
+              <a:gd name="adj" fmla="val 6000"/>
+            </a:avLst>
+          </a:prstGeom>
+          <a:noFill/>
+          <a:ln w="19050">
+            <a:solidFill>
+              <a:srgbClr val="F8F4EA"/>
+            </a:solidFill>
+            <a:prstDash val="dash"/>
+          </a:ln>
+          <a:effectLst/>
+        </p:spPr>
+        <p:style>
+          <a:lnRef idx="1">
+            <a:schemeClr val="accent1"/>
+          </a:lnRef>
+          <a:fillRef idx="3">
+            <a:schemeClr val="accent1"/>
+          </a:fillRef>
+          <a:effectRef idx="2">
+            <a:schemeClr val="accent1"/>
+          </a:effectRef>
+          <a:fontRef idx="minor">
+            <a:schemeClr val="lt1"/>
+          </a:fontRef>
+        </p:style>
+        <p:txBody>
+          <a:bodyPr rtlCol="0" anchor="ctr"/>
+          <a:lstStyle/>
+          <a:p>
+            <a:pPr algn="ctr"/>
+          </a:p>
+        </p:txBody>
+      </p:sp>
+      <p:sp>
+        <p:nvSpPr>
+          <p:cNvPr id="6" name="Rounded Rectangle 5"/>
+          <p:cNvSpPr/>
+          <p:nvPr/>
+        </p:nvSpPr>
+        <p:spPr>
+          <a:xfrm>
+            <a:off x="3917289" y="3614277"/>
+            <a:ext cx="274320" cy="274320"/>
+          </a:xfrm>
+          <a:prstGeom prst="roundRect">
+            <a:avLst>
+              <a:gd name="adj" fmla="val 25000"/>
+            </a:avLst>
           </a:prstGeom>
           <a:solidFill>
-            <a:srgbClr val="B23A2E"/>
+            <a:srgbClr val="8A3033"/>
           </a:solidFill>
-          <a:ln w="25400">
+          <a:ln w="12700">
             <a:solidFill>
               <a:srgbClr val="FFFFFF"/>
             </a:solidFill>
@@ -5315,12 +5629,12 @@
           </a:fontRef>
         </p:style>
         <p:txBody>
-          <a:bodyPr rtlCol="0" anchor="ctr" wrap="none"/>
+          <a:bodyPr rtlCol="0" anchor="ctr" lIns="0" rIns="0" tIns="0" bIns="0"/>
           <a:lstStyle/>
           <a:p>
             <a:pPr algn="ctr"/>
             <a:r>
-              <a:rPr sz="1400" b="1">
+              <a:rPr sz="1200" b="1">
                 <a:solidFill>
                   <a:srgbClr val="FFFFFF"/>
                 </a:solidFill>
@@ -5332,22 +5646,71 @@
       </p:sp>
       <p:sp>
         <p:nvSpPr>
-          <p:cNvPr id="6" name="Oval 5"/>
+          <p:cNvPr id="7" name="Rounded Rectangle 6"/>
           <p:cNvSpPr/>
           <p:nvPr/>
         </p:nvSpPr>
         <p:spPr>
           <a:xfrm>
-            <a:off x="3717950" y="2502255"/>
-            <a:ext cx="329184" cy="329184"/>
+            <a:off x="2269540" y="1788231"/>
+            <a:ext cx="3280867" cy="1660296"/>
           </a:xfrm>
-          <a:prstGeom prst="ellipse">
-            <a:avLst/>
+          <a:prstGeom prst="roundRect">
+            <a:avLst>
+              <a:gd name="adj" fmla="val 6000"/>
+            </a:avLst>
+          </a:prstGeom>
+          <a:noFill/>
+          <a:ln w="19050">
+            <a:solidFill>
+              <a:srgbClr val="F8F4EA"/>
+            </a:solidFill>
+            <a:prstDash val="dash"/>
+          </a:ln>
+          <a:effectLst/>
+        </p:spPr>
+        <p:style>
+          <a:lnRef idx="1">
+            <a:schemeClr val="accent1"/>
+          </a:lnRef>
+          <a:fillRef idx="3">
+            <a:schemeClr val="accent1"/>
+          </a:fillRef>
+          <a:effectRef idx="2">
+            <a:schemeClr val="accent1"/>
+          </a:effectRef>
+          <a:fontRef idx="minor">
+            <a:schemeClr val="lt1"/>
+          </a:fontRef>
+        </p:style>
+        <p:txBody>
+          <a:bodyPr rtlCol="0" anchor="ctr"/>
+          <a:lstStyle/>
+          <a:p>
+            <a:pPr algn="ctr"/>
+          </a:p>
+        </p:txBody>
+      </p:sp>
+      <p:sp>
+        <p:nvSpPr>
+          <p:cNvPr id="8" name="Rounded Rectangle 7"/>
+          <p:cNvSpPr/>
+          <p:nvPr/>
+        </p:nvSpPr>
+        <p:spPr>
+          <a:xfrm>
+            <a:off x="2150668" y="1669359"/>
+            <a:ext cx="274320" cy="274320"/>
+          </a:xfrm>
+          <a:prstGeom prst="roundRect">
+            <a:avLst>
+              <a:gd name="adj" fmla="val 25000"/>
+            </a:avLst>
           </a:prstGeom>
           <a:solidFill>
-            <a:srgbClr val="B23A2E"/>
+            <a:srgbClr val="8A3033"/>
           </a:solidFill>
-          <a:ln w="25400">
+          <a:ln w="12700">
             <a:solidFill>
               <a:srgbClr val="FFFFFF"/>
             </a:solidFill>
@@ -5368,12 +5731,12 @@
           </a:fontRef>
         </p:style>
         <p:txBody>
-          <a:bodyPr rtlCol="0" anchor="ctr" wrap="none"/>
+          <a:bodyPr rtlCol="0" anchor="ctr" lIns="0" rIns="0" tIns="0" bIns="0"/>
           <a:lstStyle/>
           <a:p>
             <a:pPr algn="ctr"/>
             <a:r>
-              <a:rPr sz="1400" b="1">
+              <a:rPr sz="1200" b="1">
                 <a:solidFill>
                   <a:srgbClr val="FFFFFF"/>
                 </a:solidFill>
@@ -5385,22 +5748,71 @@
       </p:sp>
       <p:sp>
         <p:nvSpPr>
-          <p:cNvPr id="7" name="Oval 6"/>
+          <p:cNvPr id="9" name="Rounded Rectangle 8"/>
           <p:cNvSpPr/>
           <p:nvPr/>
         </p:nvSpPr>
         <p:spPr>
           <a:xfrm>
-            <a:off x="3355847" y="4339925"/>
-            <a:ext cx="329184" cy="329184"/>
+            <a:off x="1890979" y="5203698"/>
+            <a:ext cx="3533241" cy="664118"/>
           </a:xfrm>
-          <a:prstGeom prst="ellipse">
-            <a:avLst/>
+          <a:prstGeom prst="roundRect">
+            <a:avLst>
+              <a:gd name="adj" fmla="val 6000"/>
+            </a:avLst>
+          </a:prstGeom>
+          <a:noFill/>
+          <a:ln w="19050">
+            <a:solidFill>
+              <a:srgbClr val="F8F4EA"/>
+            </a:solidFill>
+            <a:prstDash val="dash"/>
+          </a:ln>
+          <a:effectLst/>
+        </p:spPr>
+        <p:style>
+          <a:lnRef idx="1">
+            <a:schemeClr val="accent1"/>
+          </a:lnRef>
+          <a:fillRef idx="3">
+            <a:schemeClr val="accent1"/>
+          </a:fillRef>
+          <a:effectRef idx="2">
+            <a:schemeClr val="accent1"/>
+          </a:effectRef>
+          <a:fontRef idx="minor">
+            <a:schemeClr val="lt1"/>
+          </a:fontRef>
+        </p:style>
+        <p:txBody>
+          <a:bodyPr rtlCol="0" anchor="ctr"/>
+          <a:lstStyle/>
+          <a:p>
+            <a:pPr algn="ctr"/>
+          </a:p>
+        </p:txBody>
+      </p:sp>
+      <p:sp>
+        <p:nvSpPr>
+          <p:cNvPr id="10" name="Rounded Rectangle 9"/>
+          <p:cNvSpPr/>
+          <p:nvPr/>
+        </p:nvSpPr>
+        <p:spPr>
+          <a:xfrm>
+            <a:off x="1772107" y="5084826"/>
+            <a:ext cx="274320" cy="274320"/>
+          </a:xfrm>
+          <a:prstGeom prst="roundRect">
+            <a:avLst>
+              <a:gd name="adj" fmla="val 25000"/>
+            </a:avLst>
           </a:prstGeom>
           <a:solidFill>
-            <a:srgbClr val="B23A2E"/>
+            <a:srgbClr val="8A3033"/>
           </a:solidFill>
-          <a:ln w="25400">
+          <a:ln w="12700">
             <a:solidFill>
               <a:srgbClr val="FFFFFF"/>
             </a:solidFill>
@@ -5421,12 +5833,12 @@
           </a:fontRef>
         </p:style>
         <p:txBody>
-          <a:bodyPr rtlCol="0" anchor="ctr" wrap="none"/>
+          <a:bodyPr rtlCol="0" anchor="ctr" lIns="0" rIns="0" tIns="0" bIns="0"/>
           <a:lstStyle/>
           <a:p>
             <a:pPr algn="ctr"/>
             <a:r>
-              <a:rPr sz="1400" b="1">
+              <a:rPr sz="1200" b="1">
                 <a:solidFill>
                   <a:srgbClr val="FFFFFF"/>
                 </a:solidFill>
@@ -5438,14 +5850,14 @@
       </p:sp>
       <p:sp>
         <p:nvSpPr>
-          <p:cNvPr id="8" name="TextBox 7"/>
+          <p:cNvPr id="11" name="TextBox 10"/>
           <p:cNvSpPr txBox="1"/>
           <p:nvPr/>
         </p:nvSpPr>
         <p:spPr>
           <a:xfrm>
-            <a:off x="6858000" y="1737360"/>
-            <a:ext cx="4846320" cy="4206240"/>
+            <a:off x="7132320" y="1737360"/>
+            <a:ext cx="4572000" cy="4206240"/>
           </a:xfrm>
           <a:prstGeom prst="rect">
             <a:avLst/>
@@ -5464,13 +5876,13 @@
               </a:lnSpc>
             </a:pPr>
             <a:r>
-              <a:rPr sz="1300" b="0">
+              <a:rPr sz="1250" b="0">
                 <a:solidFill>
-                  <a:srgbClr val="241D15"/>
+                  <a:srgbClr val="211D18"/>
                 </a:solidFill>
                 <a:latin typeface="맑은 고딕"/>
               </a:rPr>
-              <a:t>1  백색 성표(White Star) — 미군 차량 공통 식별 표식. 미군 소속 차량임을 화면에서 확정.</a:t>
+              <a:t>1   백색 성표(White Star) — 미군 차량 공통 식별 표식. 미군 소속 차량임을 화면에서 확정.</a:t>
             </a:r>
           </a:p>
           <a:p>
@@ -5480,13 +5892,13 @@
               </a:lnSpc>
             </a:pPr>
             <a:r>
-              <a:rPr sz="1300" b="0">
+              <a:rPr sz="500" b="0">
                 <a:solidFill>
-                  <a:srgbClr val="241D15"/>
+                  <a:srgbClr val="211D18"/>
                 </a:solidFill>
                 <a:latin typeface="맑은 고딕"/>
               </a:rPr>
-              <a:t>2  적재함 위의 병사들 — 철수 국면에서 병력과 물자가 함께 이동했음을 보여 준다.</a:t>
+              <a:t/>
             </a:r>
           </a:p>
           <a:p>
@@ -5496,20 +5908,68 @@
               </a:lnSpc>
             </a:pPr>
             <a:r>
-              <a:rPr sz="1300" b="0">
+              <a:rPr sz="1250" b="0">
                 <a:solidFill>
-                  <a:srgbClr val="241D15"/>
+                  <a:srgbClr val="211D18"/>
                 </a:solidFill>
                 <a:latin typeface="맑은 고딕"/>
               </a:rPr>
-              <a:t>3  타임코드 00:11:58 — 같은 필름 안에서 이 장면의 서사적 위치를 특정.</a:t>
-            </a:r>
-          </a:p>
-        </p:txBody>
-      </p:sp>
-      <p:sp>
-        <p:nvSpPr>
-          <p:cNvPr id="9" name="TextBox 8"/>
+              <a:t>2   적재함 위의 병사들 — 철수 국면에서 병력과 물자가 함께 이동했음을 보여 준다.</a:t>
+            </a:r>
+          </a:p>
+          <a:p>
+            <a:pPr algn="l">
+              <a:lnSpc>
+                <a:spcPct val="130000"/>
+              </a:lnSpc>
+            </a:pPr>
+            <a:r>
+              <a:rPr sz="500" b="0">
+                <a:solidFill>
+                  <a:srgbClr val="211D18"/>
+                </a:solidFill>
+                <a:latin typeface="맑은 고딕"/>
+              </a:rPr>
+              <a:t/>
+            </a:r>
+          </a:p>
+          <a:p>
+            <a:pPr algn="l">
+              <a:lnSpc>
+                <a:spcPct val="130000"/>
+              </a:lnSpc>
+            </a:pPr>
+            <a:r>
+              <a:rPr sz="1250" b="0">
+                <a:solidFill>
+                  <a:srgbClr val="211D18"/>
+                </a:solidFill>
+                <a:latin typeface="맑은 고딕"/>
+              </a:rPr>
+              <a:t>3   타임코드 00:11:58 — 같은 필름 안에서 이 장면의 서사적 위치를 특정.</a:t>
+            </a:r>
+          </a:p>
+          <a:p>
+            <a:pPr algn="l">
+              <a:lnSpc>
+                <a:spcPct val="130000"/>
+              </a:lnSpc>
+            </a:pPr>
+            <a:r>
+              <a:rPr sz="500" b="0">
+                <a:solidFill>
+                  <a:srgbClr val="211D18"/>
+                </a:solidFill>
+                <a:latin typeface="맑은 고딕"/>
+              </a:rPr>
+              <a:t/>
+            </a:r>
+          </a:p>
+        </p:txBody>
+      </p:sp>
+      <p:sp>
+        <p:nvSpPr>
+          <p:cNvPr id="12" name="TextBox 11"/>
           <p:cNvSpPr txBox="1"/>
           <p:nvPr/>
         </p:nvSpPr>

</xml_diff>